<commit_message>
The template is 16:9
It was 4:3 — 9144000 x 6858000 EMU — which is what the workbench outline
was faithfully drawing. The outline was not wrong; the deck was the
shape it said.

Widened to 12192000 EMU, the same height, with every horizontal offset
and extent scaled by the same 4/3 so the design keeps its proportions
rather than sitting in a column beside an empty band. 110 measurements
across 12 parts. layout-geometry.json regenerated from the result,
because it records where the placeholders are and they have all moved.

Done with edufair-widescreen, which exists now so the next library made
before the seed was widened does not need this reconstructing. Checked
after: every session renders, no warnings, and no placeholder runs past
an edge.

Co-Authored-By: Claude Opus 5 <noreply@anthropic.com>
</commit_message>
<xml_diff>
--- a/template.pptx
+++ b/template.pptx
@@ -4,7 +4,8 @@
   <p:sldMasterIdLst>
     <p:sldMasterId id="2147483648" r:id="rId1"/>
   </p:sldMasterIdLst>
-  <p:sldSz cx="9144000" cy="6858000" type="screen4x3"/>
+  <p:sldIdLst/>
+  <p:sldSz cx="12192000" cy="6858000" type="screen4x3"/>
   <p:notesSz cx="6858000" cy="9144000"/>
   <p:defaultTextStyle>
     <a:defPPr>
@@ -133,8 +134,8 @@
         </p:nvSpPr>
         <p:spPr>
           <a:xfrm>
-            <a:off x="685800" y="2130425"/>
-            <a:ext cx="7772400" cy="1470025"/>
+            <a:off x="914400" y="2130425"/>
+            <a:ext cx="10363200" cy="1470025"/>
           </a:xfrm>
         </p:spPr>
         <p:txBody>
@@ -161,8 +162,8 @@
         </p:nvSpPr>
         <p:spPr>
           <a:xfrm>
-            <a:off x="1371600" y="3886200"/>
-            <a:ext cx="6400800" cy="1752600"/>
+            <a:off x="1828800" y="3886200"/>
+            <a:ext cx="8534400" cy="1752600"/>
           </a:xfrm>
         </p:spPr>
         <p:txBody>
@@ -463,8 +464,8 @@
         </p:nvSpPr>
         <p:spPr>
           <a:xfrm>
-            <a:off x="301752" y="1645920"/>
-            <a:ext cx="2018538" cy="502920"/>
+            <a:off x="402336" y="1645920"/>
+            <a:ext cx="2691384" cy="502920"/>
           </a:xfrm>
           <a:prstGeom prst="round2SameRect">
             <a:avLst>
@@ -505,8 +506,8 @@
         </p:nvSpPr>
         <p:spPr>
           <a:xfrm>
-            <a:off x="301752" y="2148840"/>
-            <a:ext cx="2018538" cy="4343400"/>
+            <a:off x="402336" y="2148840"/>
+            <a:ext cx="2691384" cy="4343400"/>
           </a:xfrm>
           <a:prstGeom prst="rect">
             <a:avLst/>
@@ -544,8 +545,8 @@
         </p:nvSpPr>
         <p:spPr>
           <a:xfrm>
-            <a:off x="2475738" y="1645920"/>
-            <a:ext cx="2018538" cy="502920"/>
+            <a:off x="3300984" y="1645920"/>
+            <a:ext cx="2691384" cy="502920"/>
           </a:xfrm>
           <a:prstGeom prst="round2SameRect">
             <a:avLst>
@@ -586,8 +587,8 @@
         </p:nvSpPr>
         <p:spPr>
           <a:xfrm>
-            <a:off x="2475738" y="2148840"/>
-            <a:ext cx="2018538" cy="4343400"/>
+            <a:off x="3300984" y="2148840"/>
+            <a:ext cx="2691384" cy="4343400"/>
           </a:xfrm>
           <a:prstGeom prst="rect">
             <a:avLst/>
@@ -625,8 +626,8 @@
         </p:nvSpPr>
         <p:spPr>
           <a:xfrm>
-            <a:off x="4649724" y="1645920"/>
-            <a:ext cx="2018538" cy="502920"/>
+            <a:off x="6199632" y="1645920"/>
+            <a:ext cx="2691384" cy="502920"/>
           </a:xfrm>
           <a:prstGeom prst="round2SameRect">
             <a:avLst>
@@ -667,8 +668,8 @@
         </p:nvSpPr>
         <p:spPr>
           <a:xfrm>
-            <a:off x="4649724" y="2148840"/>
-            <a:ext cx="2018538" cy="4343400"/>
+            <a:off x="6199632" y="2148840"/>
+            <a:ext cx="2691384" cy="4343400"/>
           </a:xfrm>
           <a:prstGeom prst="rect">
             <a:avLst/>
@@ -706,8 +707,8 @@
         </p:nvSpPr>
         <p:spPr>
           <a:xfrm>
-            <a:off x="6823710" y="1645920"/>
-            <a:ext cx="2018538" cy="502920"/>
+            <a:off x="9098280" y="1645920"/>
+            <a:ext cx="2691384" cy="502920"/>
           </a:xfrm>
           <a:prstGeom prst="round2SameRect">
             <a:avLst>
@@ -748,8 +749,8 @@
         </p:nvSpPr>
         <p:spPr>
           <a:xfrm>
-            <a:off x="6823710" y="2148840"/>
-            <a:ext cx="2018538" cy="4343400"/>
+            <a:off x="9098280" y="2148840"/>
+            <a:ext cx="2691384" cy="4343400"/>
           </a:xfrm>
           <a:prstGeom prst="rect">
             <a:avLst/>
@@ -817,8 +818,8 @@
         </p:nvSpPr>
         <p:spPr>
           <a:xfrm>
-            <a:off x="6629400" y="274638"/>
-            <a:ext cx="2057400" cy="5851525"/>
+            <a:off x="8839200" y="274638"/>
+            <a:ext cx="2743200" cy="5851525"/>
           </a:xfrm>
         </p:spPr>
         <p:txBody>
@@ -845,8 +846,8 @@
         </p:nvSpPr>
         <p:spPr>
           <a:xfrm>
-            <a:off x="457200" y="274638"/>
-            <a:ext cx="6019800" cy="5851525"/>
+            <a:off x="609600" y="274638"/>
+            <a:ext cx="8026400" cy="5851525"/>
           </a:xfrm>
         </p:spPr>
         <p:txBody>
@@ -1167,8 +1168,8 @@
         </p:nvSpPr>
         <p:spPr>
           <a:xfrm>
-            <a:off x="722313" y="4406900"/>
-            <a:ext cx="7772400" cy="1362075"/>
+            <a:off x="963084" y="4406900"/>
+            <a:ext cx="10363200" cy="1362075"/>
           </a:xfrm>
         </p:spPr>
         <p:txBody>
@@ -1199,8 +1200,8 @@
         </p:nvSpPr>
         <p:spPr>
           <a:xfrm>
-            <a:off x="722313" y="2906713"/>
-            <a:ext cx="7772400" cy="1500187"/>
+            <a:off x="963084" y="2906713"/>
+            <a:ext cx="10363200" cy="1500187"/>
           </a:xfrm>
         </p:spPr>
         <p:txBody>
@@ -1436,8 +1437,8 @@
         </p:nvSpPr>
         <p:spPr>
           <a:xfrm>
-            <a:off x="457200" y="1600200"/>
-            <a:ext cx="4038600" cy="4525963"/>
+            <a:off x="609600" y="1600200"/>
+            <a:ext cx="5384800" cy="4525963"/>
           </a:xfrm>
         </p:spPr>
         <p:txBody>
@@ -1521,8 +1522,8 @@
         </p:nvSpPr>
         <p:spPr>
           <a:xfrm>
-            <a:off x="4648200" y="1600200"/>
-            <a:ext cx="4038600" cy="4525963"/>
+            <a:off x="6197600" y="1600200"/>
+            <a:ext cx="5384800" cy="4525963"/>
           </a:xfrm>
         </p:spPr>
         <p:txBody>
@@ -1728,8 +1729,8 @@
         </p:nvSpPr>
         <p:spPr>
           <a:xfrm>
-            <a:off x="457200" y="1535113"/>
-            <a:ext cx="4040188" cy="639762"/>
+            <a:off x="609600" y="1535113"/>
+            <a:ext cx="5386917" cy="639762"/>
           </a:xfrm>
         </p:spPr>
         <p:txBody>
@@ -1793,8 +1794,8 @@
         </p:nvSpPr>
         <p:spPr>
           <a:xfrm>
-            <a:off x="457200" y="2174875"/>
-            <a:ext cx="4040188" cy="3951288"/>
+            <a:off x="609600" y="2174875"/>
+            <a:ext cx="5386917" cy="3951288"/>
           </a:xfrm>
         </p:spPr>
         <p:txBody>
@@ -1878,8 +1879,8 @@
         </p:nvSpPr>
         <p:spPr>
           <a:xfrm>
-            <a:off x="4645025" y="1535113"/>
-            <a:ext cx="4041775" cy="639762"/>
+            <a:off x="6193367" y="1535113"/>
+            <a:ext cx="5389033" cy="639762"/>
           </a:xfrm>
         </p:spPr>
         <p:txBody>
@@ -1943,8 +1944,8 @@
         </p:nvSpPr>
         <p:spPr>
           <a:xfrm>
-            <a:off x="4645025" y="2174875"/>
-            <a:ext cx="4041775" cy="3951288"/>
+            <a:off x="6193367" y="2174875"/>
+            <a:ext cx="5389033" cy="3951288"/>
           </a:xfrm>
         </p:spPr>
         <p:txBody>
@@ -2336,8 +2337,8 @@
         </p:nvSpPr>
         <p:spPr>
           <a:xfrm>
-            <a:off x="457200" y="273050"/>
-            <a:ext cx="3008313" cy="1162050"/>
+            <a:off x="609600" y="273050"/>
+            <a:ext cx="4011084" cy="1162050"/>
           </a:xfrm>
         </p:spPr>
         <p:txBody>
@@ -2368,8 +2369,8 @@
         </p:nvSpPr>
         <p:spPr>
           <a:xfrm>
-            <a:off x="3575050" y="273050"/>
-            <a:ext cx="5111750" cy="5853113"/>
+            <a:off x="4766733" y="273050"/>
+            <a:ext cx="6815667" cy="5853113"/>
           </a:xfrm>
         </p:spPr>
         <p:txBody>
@@ -2453,8 +2454,8 @@
         </p:nvSpPr>
         <p:spPr>
           <a:xfrm>
-            <a:off x="457200" y="1435100"/>
-            <a:ext cx="3008313" cy="4691063"/>
+            <a:off x="609600" y="1435100"/>
+            <a:ext cx="4011084" cy="4691063"/>
           </a:xfrm>
         </p:spPr>
         <p:txBody>
@@ -2613,8 +2614,8 @@
         </p:nvSpPr>
         <p:spPr>
           <a:xfrm>
-            <a:off x="1792288" y="4800600"/>
-            <a:ext cx="5486400" cy="566738"/>
+            <a:off x="2389717" y="4800600"/>
+            <a:ext cx="7315200" cy="566738"/>
           </a:xfrm>
         </p:spPr>
         <p:txBody>
@@ -2645,8 +2646,8 @@
         </p:nvSpPr>
         <p:spPr>
           <a:xfrm>
-            <a:off x="1792288" y="612775"/>
-            <a:ext cx="5486400" cy="4114800"/>
+            <a:off x="2389717" y="612775"/>
+            <a:ext cx="7315200" cy="4114800"/>
           </a:xfrm>
         </p:spPr>
         <p:txBody>
@@ -2706,8 +2707,8 @@
         </p:nvSpPr>
         <p:spPr>
           <a:xfrm>
-            <a:off x="1792288" y="5367338"/>
-            <a:ext cx="5486400" cy="804862"/>
+            <a:off x="2389717" y="5367338"/>
+            <a:ext cx="7315200" cy="804862"/>
           </a:xfrm>
         </p:spPr>
         <p:txBody>
@@ -2871,8 +2872,8 @@
         </p:nvSpPr>
         <p:spPr>
           <a:xfrm>
-            <a:off x="457200" y="274638"/>
-            <a:ext cx="8229600" cy="1143000"/>
+            <a:off x="609600" y="274638"/>
+            <a:ext cx="10972800" cy="1143000"/>
           </a:xfrm>
           <a:prstGeom prst="rect">
             <a:avLst/>
@@ -2904,8 +2905,8 @@
         </p:nvSpPr>
         <p:spPr>
           <a:xfrm>
-            <a:off x="457200" y="1600200"/>
-            <a:ext cx="8229600" cy="4525963"/>
+            <a:off x="609600" y="1600200"/>
+            <a:ext cx="10972800" cy="4525963"/>
           </a:xfrm>
           <a:prstGeom prst="rect">
             <a:avLst/>
@@ -2966,8 +2967,8 @@
         </p:nvSpPr>
         <p:spPr>
           <a:xfrm>
-            <a:off x="457200" y="6356350"/>
-            <a:ext cx="2133600" cy="365125"/>
+            <a:off x="609600" y="6356350"/>
+            <a:ext cx="2844800" cy="365125"/>
           </a:xfrm>
           <a:prstGeom prst="rect">
             <a:avLst/>
@@ -3007,8 +3008,8 @@
         </p:nvSpPr>
         <p:spPr>
           <a:xfrm>
-            <a:off x="3124200" y="6356350"/>
-            <a:ext cx="2895600" cy="365125"/>
+            <a:off x="4165600" y="6356350"/>
+            <a:ext cx="3860800" cy="365125"/>
           </a:xfrm>
           <a:prstGeom prst="rect">
             <a:avLst/>
@@ -3044,8 +3045,8 @@
         </p:nvSpPr>
         <p:spPr>
           <a:xfrm>
-            <a:off x="6553200" y="6356350"/>
-            <a:ext cx="2133600" cy="365125"/>
+            <a:off x="8737600" y="6356350"/>
+            <a:ext cx="2844800" cy="365125"/>
           </a:xfrm>
           <a:prstGeom prst="rect">
             <a:avLst/>

</xml_diff>